<commit_message>
Add a presenter script and defense guide; drop a stale slide 6 bullet
New step 09d (src/09d_build_presentation_script.py, standard library
only) writes reports/presentation/presentation_script.md and a printable
.html. It follows the 12 slides: what to say on each, every idea in
plain words, likely questions with answers, the numbers to remember and
what not to say. Every number is read from the result files, so it
matches the slides and the report.

Slide 6 said "Those were not chosen in advance, and their meaning is
unclear" although no feature passes FDR. 09c now writes that bullet only
when there are such features, and the bullet is removed from the built
deck (one paragraph of slide6.xml; nothing else changed).

The runner, the submission package, README and RUNNING.md list the new
step and files.

Co-Authored-By: Claude Opus 5.5 <noreply@anthropic.com>
</commit_message>
<xml_diff>
--- a/reports/presentation/G3_results_presentation.pptx
+++ b/reports/presentation/G3_results_presentation.pptx
@@ -9811,23 +9811,6 @@
                 </a:solidFill>
                 <a:latin typeface="Calibri"/>
               </a:rPr>
-              <a:t>Those were not chosen in advance, and their meaning is unclear</a:t>
-            </a:r>
-          </a:p>
-          <a:p>
-            <a:pPr algn="l" marL="274320" indent="-274320">
-              <a:spcAft>
-                <a:spcPts val="600"/>
-              </a:spcAft>
-              <a:buChar char="•"/>
-            </a:pPr>
-            <a:r>
-              <a:rPr sz="1500" b="0">
-                <a:solidFill>
-                  <a:srgbClr val="1C1C1A"/>
-                </a:solidFill>
-                <a:latin typeface="Calibri"/>
-              </a:rPr>
               <a:t>With n = 40, only correlations of about |ρ| ≥ 0.44 can be detected reliably (80% power)</a:t>
             </a:r>
           </a:p>

</xml_diff>